<commit_message>
fix: capturas 'antes' simuladas (proto de cubos) y infografia AA4 con pares antes/despues correctos
</commit_message>
<xml_diff>
--- a/Docs/Evidencias/GA5-AA4-EV01_Infografia.pptx
+++ b/Docs/Evidencias/GA5-AA4-EV01_Infografia.pptx
@@ -3338,7 +3338,7 @@
                 </a:solidFill>
                 <a:latin typeface="Arial"/>
               </a:rPr>
-              <a:t>Una sola escena de prueba con menú y HUD por código (OnGUI), sin navegación.</a:t>
+              <a:t>Prototipo inicial: una sola escena con menú y HUD en texto plano, sin navegación.</a:t>
             </a:r>
           </a:p>
         </p:txBody>
@@ -3400,7 +3400,7 @@
       </p:sp>
       <p:pic>
         <p:nvPicPr>
-          <p:cNvPr id="9" name="Picture 8" descr="03_Gameplay_HUD_original.png"/>
+          <p:cNvPr id="9" name="Picture 8" descr="legacy_menu.png"/>
           <p:cNvPicPr>
             <a:picLocks noChangeAspect="1"/>
           </p:cNvPicPr>
@@ -3414,8 +3414,8 @@
         </p:blipFill>
         <p:spPr>
           <a:xfrm>
-            <a:off x="365760" y="3154680"/>
-            <a:ext cx="2926080" cy="1828800"/>
+            <a:off x="365760" y="3246120"/>
+            <a:ext cx="2926080" cy="1645920"/>
           </a:xfrm>
           <a:prstGeom prst="rect">
             <a:avLst/>
@@ -3424,7 +3424,7 @@
       </p:pic>
       <p:pic>
         <p:nvPicPr>
-          <p:cNvPr id="10" name="Picture 9" descr="gameplay_impacto_checkpoint_turbo.png"/>
+          <p:cNvPr id="10" name="Picture 9" descr="ui_menu_principal.png"/>
           <p:cNvPicPr>
             <a:picLocks noChangeAspect="1"/>
           </p:cNvPicPr>
@@ -3535,7 +3535,7 @@
                 </a:solidFill>
                 <a:latin typeface="Arial"/>
               </a:rPr>
-              <a:t>Primitivas cúbicas de color plano; sin audio reactivo.</a:t>
+              <a:t>Primitivas cúbicas de color plano; sin garaje 3D ni audio reactivo.</a:t>
             </a:r>
           </a:p>
         </p:txBody>
@@ -3590,14 +3590,14 @@
                 </a:solidFill>
                 <a:latin typeface="Arial"/>
               </a:rPr>
-              <a:t>Karts y pilotos 3D texturizados, estética neón URP y música/SFX sintetizados.</a:t>
+              <a:t>Karts y pilotos 3D texturizados, garaje 3D y estética neón URP.</a:t>
             </a:r>
           </a:p>
         </p:txBody>
       </p:sp>
       <p:pic>
         <p:nvPicPr>
-          <p:cNvPr id="14" name="Picture 13" descr="02_CharacterSelect_original.png"/>
+          <p:cNvPr id="14" name="Picture 13" descr="legacy_select.png"/>
           <p:cNvPicPr>
             <a:picLocks noChangeAspect="1"/>
           </p:cNvPicPr>
@@ -3611,8 +3611,8 @@
         </p:blipFill>
         <p:spPr>
           <a:xfrm>
-            <a:off x="365760" y="6355079"/>
-            <a:ext cx="2926080" cy="1828800"/>
+            <a:off x="365760" y="6446520"/>
+            <a:ext cx="2926080" cy="1645920"/>
           </a:xfrm>
           <a:prstGeom prst="rect">
             <a:avLst/>
@@ -3732,7 +3732,7 @@
                 </a:solidFill>
                 <a:latin typeface="Arial"/>
               </a:rPr>
-              <a:t>Pista procedural lineal sin temática ni narrativa.</a:t>
+              <a:t>Pista de un solo estilo: plataformas grises de cubos, sin temática.</a:t>
             </a:r>
           </a:p>
         </p:txBody>
@@ -3794,7 +3794,7 @@
       </p:sp>
       <p:pic>
         <p:nvPicPr>
-          <p:cNvPr id="19" name="Picture 18" descr="gameplay_cubos_y_un_solo_estilo.png"/>
+          <p:cNvPr id="19" name="Picture 18" descr="legacy_track.png"/>
           <p:cNvPicPr>
             <a:picLocks noChangeAspect="1"/>
           </p:cNvPicPr>
@@ -3929,7 +3929,7 @@
                 </a:solidFill>
                 <a:latin typeface="Arial"/>
               </a:rPr>
-              <a:t>Movimiento básico y villano estático.</a:t>
+              <a:t>Karts y villano de cubos; movimiento básico y sin combate.</a:t>
             </a:r>
           </a:p>
         </p:txBody>
@@ -3984,14 +3984,14 @@
                 </a:solidFill>
                 <a:latin typeface="Arial"/>
               </a:rPr>
-              <a:t>4 modos, villano que ataca al compás, K.O. con cuenta regresiva, bot que salta huecos y feedback de impacto.</a:t>
+              <a:t>4 modos, villano que ataca al compás y K.O. con cuenta regresiva y feedback de impacto.</a:t>
             </a:r>
           </a:p>
         </p:txBody>
       </p:sp>
       <p:pic>
         <p:nvPicPr>
-          <p:cNvPr id="24" name="Picture 23" descr="villano_ataque.png"/>
+          <p:cNvPr id="24" name="Picture 23" descr="legacy_gameplay.png"/>
           <p:cNvPicPr>
             <a:picLocks noChangeAspect="1"/>
           </p:cNvPicPr>
@@ -4046,7 +4046,7 @@
         <p:spPr>
           <a:xfrm>
             <a:off x="365760" y="14904720"/>
-            <a:ext cx="6126480" cy="914400"/>
+            <a:ext cx="6126480" cy="1097280"/>
           </a:xfrm>
           <a:prstGeom prst="rect">
             <a:avLst/>
@@ -4072,6 +4072,22 @@
                 <a:latin typeface="Arial"/>
               </a:rPr>
               <a:t>Hallazgos P4 (HUD), P6 (impacto) y P9 (progresión) atendidos y verificados con 40 pruebas automáticas.</a:t>
+            </a:r>
+          </a:p>
+          <a:p>
+            <a:pPr algn="ctr">
+              <a:lnSpc>
+                <a:spcPct val="100000"/>
+              </a:lnSpc>
+            </a:pPr>
+            <a:r>
+              <a:rPr sz="1000" b="0">
+                <a:solidFill>
+                  <a:srgbClr val="9A9AB0"/>
+                </a:solidFill>
+                <a:latin typeface="Arial"/>
+              </a:rPr>
+              <a:t>El estado «antes» se reconstruye a partir del prototipo inicial (primitivas, sin garaje 3D).</a:t>
             </a:r>
           </a:p>
           <a:p>

</xml_diff>